<commit_message>
docs(presentation): weave GEPA into slide, refocus innovation 3 and value panel
Surface the in-progress GEPA integration inside the existing flow (skills
store engine line, nightly release step, innovation 2 merged with the
eval gate) without making it a headline item. Innovation 3 now leads
with zero-intrusion developer experience (unchanged habits, MCP plug-in,
silent degradation) with the automated loop as the means. The value
panel drops measured-result charts in favor of expected-benefit visuals:
a compounding-experience concept curve (with/without hub), a target
improvement bar chart, and a progress footnote (pipeline proven offline,
GEPA integration underway, device gains to be backfilled from pilots).

Co-Authored-By: Claude Fable 5 <noreply@anthropic.com>
Claude-Session: https://claude.ai/code/session_01CH5BZimuCNgDD7CqCtcHvu
</commit_message>
<xml_diff>
--- a/docs/presentation/skill_hub_proposal_onepager.pptx
+++ b/docs/presentation/skill_hub_proposal_onepager.pptx
@@ -115,9 +115,7 @@
     <c:autoTitleDeleted val="1"/>
     <c:plotArea>
       <c:layout/>
-      <c:barChart>
-        <c:barDir val="col"/>
-        <c:grouping val="clustered"/>
+      <c:lineChart>
         <c:varyColors val="0"/>
         <c:ser>
           <c:idx val="0"/>
@@ -128,7 +126,7 @@
               <c:strCache>
                 <c:ptCount val="1"/>
                 <c:pt idx="0">
-                  <c:v>优化前</c:v>
+                  <c:v>无 Hub</c:v>
                 </c:pt>
               </c:strCache>
             </c:strRef>
@@ -137,47 +135,80 @@
             <a:solidFill>
               <a:srgbClr val="BFBFBF"/>
             </a:solidFill>
+            <a:ln w="22225" cap="flat">
+              <a:solidFill>
+                <a:srgbClr val="BFBFBF"/>
+              </a:solidFill>
+              <a:prstDash val="solid"/>
+              <a:round/>
+            </a:ln>
             <a:effectLst/>
           </c:spPr>
           <c:invertIfNegative val="0"/>
           <c:dLbls>
-            <c:numFmt formatCode="0.0#" sourceLinked="0"/>
+            <c:numFmt formatCode="#,##0" sourceLinked="0"/>
             <c:txPr>
               <a:bodyPr/>
               <a:lstStyle/>
               <a:p>
                 <a:pPr>
-                  <a:defRPr b="0" i="0" strike="noStrike" sz="600" u="none">
+                  <a:defRPr b="0" i="0" strike="noStrike" sz="1200" u="none">
                     <a:solidFill>
-                      <a:srgbClr val="404040"/>
+                      <a:srgbClr val="000000"/>
                     </a:solidFill>
-                    <a:latin typeface="Microsoft YaHei"/>
+                    <a:latin typeface="Arial"/>
                   </a:defRPr>
                 </a:pPr>
               </a:p>
             </c:txPr>
             <c:showLegendKey val="0"/>
-            <c:showVal val="1"/>
+            <c:showVal val="0"/>
             <c:showCatName val="0"/>
             <c:showSerName val="0"/>
             <c:showPercent val="0"/>
             <c:showBubbleSize val="0"/>
             <c:showLeaderLines val="0"/>
           </c:dLbls>
+          <c:marker>
+            <c:symbol val="none"/>
+            <c:size val="6"/>
+            <c:spPr>
+              <a:solidFill>
+                <a:srgbClr val="BFBFBF"/>
+              </a:solidFill>
+              <a:ln w="9525" cap="flat">
+                <a:solidFill>
+                  <a:srgbClr val="BFBFBF"/>
+                </a:solidFill>
+                <a:prstDash val="solid"/>
+                <a:round/>
+              </a:ln>
+              <a:effectLst/>
+            </c:spPr>
+          </c:marker>
           <c:cat>
             <c:multiLvlStrRef>
-              <c:f>Sheet1!$A$2:$A$4</c:f>
+              <c:f>Sheet1!$A$2:$A$7</c:f>
               <c:multiLvlStrCache>
-                <c:ptCount val="3"/>
+                <c:ptCount val="6"/>
                 <c:lvl>
                   <c:pt idx="0">
-                    <c:v>hh 系</c:v>
+                    <c:v>1</c:v>
                   </c:pt>
                   <c:pt idx="1">
-                    <c:v>mm 系</c:v>
+                    <c:v>2</c:v>
                   </c:pt>
                   <c:pt idx="2">
-                    <c:v>wq 系</c:v>
+                    <c:v>3</c:v>
+                  </c:pt>
+                  <c:pt idx="3">
+                    <c:v>4</c:v>
+                  </c:pt>
+                  <c:pt idx="4">
+                    <c:v>5</c:v>
+                  </c:pt>
+                  <c:pt idx="5">
+                    <c:v>6</c:v>
                   </c:pt>
                 </c:lvl>
               </c:multiLvlStrCache>
@@ -185,22 +216,32 @@
           </c:cat>
           <c:val>
             <c:numRef>
-              <c:f>Sheet1!$B$2:$B$4</c:f>
+              <c:f>Sheet1!$B$2:$B$7</c:f>
               <c:numCache>
                 <c:formatCode>General</c:formatCode>
-                <c:ptCount val="3"/>
+                <c:ptCount val="6"/>
                 <c:pt idx="0">
-                  <c:v>1</c:v>
+                  <c:v>10</c:v>
                 </c:pt>
                 <c:pt idx="1">
-                  <c:v>0.2</c:v>
+                  <c:v>12</c:v>
                 </c:pt>
                 <c:pt idx="2">
-                  <c:v>1</c:v>
+                  <c:v>9</c:v>
+                </c:pt>
+                <c:pt idx="3">
+                  <c:v>13</c:v>
+                </c:pt>
+                <c:pt idx="4">
+                  <c:v>10</c:v>
+                </c:pt>
+                <c:pt idx="5">
+                  <c:v>12</c:v>
                 </c:pt>
               </c:numCache>
             </c:numRef>
           </c:val>
+          <c:smooth val="1"/>
         </c:ser>
         <c:ser>
           <c:idx val="1"/>
@@ -211,7 +252,7 @@
               <c:strCache>
                 <c:ptCount val="1"/>
                 <c:pt idx="0">
-                  <c:v>优化后</c:v>
+                  <c:v>有 Hub</c:v>
                 </c:pt>
               </c:strCache>
             </c:strRef>
@@ -220,47 +261,80 @@
             <a:solidFill>
               <a:srgbClr val="C00000"/>
             </a:solidFill>
+            <a:ln w="22225" cap="flat">
+              <a:solidFill>
+                <a:srgbClr val="C00000"/>
+              </a:solidFill>
+              <a:prstDash val="solid"/>
+              <a:round/>
+            </a:ln>
             <a:effectLst/>
           </c:spPr>
           <c:invertIfNegative val="0"/>
           <c:dLbls>
-            <c:numFmt formatCode="0.0#" sourceLinked="0"/>
+            <c:numFmt formatCode="#,##0" sourceLinked="0"/>
             <c:txPr>
               <a:bodyPr/>
               <a:lstStyle/>
               <a:p>
                 <a:pPr>
-                  <a:defRPr b="0" i="0" strike="noStrike" sz="600" u="none">
+                  <a:defRPr b="0" i="0" strike="noStrike" sz="1200" u="none">
                     <a:solidFill>
-                      <a:srgbClr val="404040"/>
+                      <a:srgbClr val="000000"/>
                     </a:solidFill>
-                    <a:latin typeface="Microsoft YaHei"/>
+                    <a:latin typeface="Arial"/>
                   </a:defRPr>
                 </a:pPr>
               </a:p>
             </c:txPr>
             <c:showLegendKey val="0"/>
-            <c:showVal val="1"/>
+            <c:showVal val="0"/>
             <c:showCatName val="0"/>
             <c:showSerName val="0"/>
             <c:showPercent val="0"/>
             <c:showBubbleSize val="0"/>
             <c:showLeaderLines val="0"/>
           </c:dLbls>
+          <c:marker>
+            <c:symbol val="none"/>
+            <c:size val="6"/>
+            <c:spPr>
+              <a:solidFill>
+                <a:srgbClr val="C00000"/>
+              </a:solidFill>
+              <a:ln w="9525" cap="flat">
+                <a:solidFill>
+                  <a:srgbClr val="C00000"/>
+                </a:solidFill>
+                <a:prstDash val="solid"/>
+                <a:round/>
+              </a:ln>
+              <a:effectLst/>
+            </c:spPr>
+          </c:marker>
           <c:cat>
             <c:multiLvlStrRef>
-              <c:f>Sheet1!$A$2:$A$4</c:f>
+              <c:f>Sheet1!$A$2:$A$7</c:f>
               <c:multiLvlStrCache>
-                <c:ptCount val="3"/>
+                <c:ptCount val="6"/>
                 <c:lvl>
                   <c:pt idx="0">
-                    <c:v>hh 系</c:v>
+                    <c:v>1</c:v>
                   </c:pt>
                   <c:pt idx="1">
-                    <c:v>mm 系</c:v>
+                    <c:v>2</c:v>
                   </c:pt>
                   <c:pt idx="2">
-                    <c:v>wq 系</c:v>
+                    <c:v>3</c:v>
+                  </c:pt>
+                  <c:pt idx="3">
+                    <c:v>4</c:v>
+                  </c:pt>
+                  <c:pt idx="4">
+                    <c:v>5</c:v>
+                  </c:pt>
+                  <c:pt idx="5">
+                    <c:v>6</c:v>
                   </c:pt>
                 </c:lvl>
               </c:multiLvlStrCache>
@@ -268,53 +342,62 @@
           </c:cat>
           <c:val>
             <c:numRef>
-              <c:f>Sheet1!$C$2:$C$4</c:f>
+              <c:f>Sheet1!$C$2:$C$7</c:f>
               <c:numCache>
                 <c:formatCode>General</c:formatCode>
-                <c:ptCount val="3"/>
+                <c:ptCount val="6"/>
                 <c:pt idx="0">
-                  <c:v>1</c:v>
+                  <c:v>10</c:v>
                 </c:pt>
                 <c:pt idx="1">
-                  <c:v>1</c:v>
+                  <c:v>22</c:v>
                 </c:pt>
                 <c:pt idx="2">
-                  <c:v>1</c:v>
+                  <c:v>36</c:v>
+                </c:pt>
+                <c:pt idx="3">
+                  <c:v>52</c:v>
+                </c:pt>
+                <c:pt idx="4">
+                  <c:v>70</c:v>
+                </c:pt>
+                <c:pt idx="5">
+                  <c:v>90</c:v>
                 </c:pt>
               </c:numCache>
             </c:numRef>
           </c:val>
+          <c:smooth val="1"/>
         </c:ser>
         <c:dLbls>
-          <c:numFmt formatCode="0.0#" sourceLinked="0"/>
+          <c:numFmt formatCode="#,##0" sourceLinked="0"/>
           <c:txPr>
             <a:bodyPr/>
             <a:lstStyle/>
             <a:p>
               <a:pPr>
-                <a:defRPr b="0" i="0" strike="noStrike" sz="600" u="none">
+                <a:defRPr b="0" i="0" strike="noStrike" sz="1200" u="none">
                   <a:solidFill>
-                    <a:srgbClr val="404040"/>
+                    <a:srgbClr val="000000"/>
                   </a:solidFill>
-                  <a:latin typeface="Microsoft YaHei"/>
+                  <a:latin typeface="Arial"/>
                 </a:defRPr>
               </a:pPr>
             </a:p>
           </c:txPr>
           <c:showLegendKey val="0"/>
-          <c:showVal val="1"/>
+          <c:showVal val="0"/>
           <c:showCatName val="0"/>
           <c:showSerName val="0"/>
           <c:showPercent val="0"/>
           <c:showBubbleSize val="0"/>
           <c:showLeaderLines val="0"/>
         </c:dLbls>
-        <c:gapWidth val="40"/>
-        <c:overlap val="0"/>
+        <c:marker val="1"/>
         <c:axId val="2094734554"/>
         <c:axId val="2094734552"/>
         <c:axId val="2094734556"/>
-      </c:barChart>
+      </c:lineChart>
       <c:catAx>
         <c:axId val="2094734554"/>
         <c:scaling>
@@ -340,7 +423,7 @@
           <a:lstStyle/>
           <a:p>
             <a:pPr>
-              <a:defRPr sz="650" b="0" i="0" u="none" strike="noStrike">
+              <a:defRPr sz="600" b="0" i="0" u="none" strike="noStrike">
                 <a:solidFill>
                   <a:srgbClr val="404040"/>
                 </a:solidFill>
@@ -360,7 +443,6 @@
         <c:axId val="2094734552"/>
         <c:scaling>
           <c:orientation val="minMax"/>
-          <c:max val="1.2"/>
           <c:min val="0"/>
         </c:scaling>
         <c:delete val="1"/>
@@ -459,7 +541,7 @@
               <c:strCache>
                 <c:ptCount val="1"/>
                 <c:pt idx="0">
-                  <c:v>recall@5</c:v>
+                  <c:v>改善幅度</c:v>
                 </c:pt>
               </c:strCache>
             </c:strRef>
@@ -472,7 +554,7 @@
           </c:spPr>
           <c:invertIfNegative val="0"/>
           <c:dLbls>
-            <c:numFmt formatCode="0.0#" sourceLinked="0"/>
+            <c:numFmt formatCode="0&quot;%&quot;" sourceLinked="0"/>
             <c:txPr>
               <a:bodyPr/>
               <a:lstStyle/>
@@ -502,13 +584,13 @@
                 <c:ptCount val="3"/>
                 <c:lvl>
                   <c:pt idx="0">
-                    <c:v>BM25</c:v>
+                    <c:v>重复探索</c:v>
                   </c:pt>
                   <c:pt idx="1">
-                    <c:v>向量</c:v>
+                    <c:v>冷启动</c:v>
                   </c:pt>
                   <c:pt idx="2">
-                    <c:v>混合</c:v>
+                    <c:v>命中率</c:v>
                   </c:pt>
                 </c:lvl>
               </c:multiLvlStrCache>
@@ -521,20 +603,20 @@
                 <c:formatCode>General</c:formatCode>
                 <c:ptCount val="3"/>
                 <c:pt idx="0">
-                  <c:v>1</c:v>
+                  <c:v>50</c:v>
                 </c:pt>
                 <c:pt idx="1">
-                  <c:v>0.8</c:v>
+                  <c:v>70</c:v>
                 </c:pt>
                 <c:pt idx="2">
-                  <c:v>1</c:v>
+                  <c:v>30</c:v>
                 </c:pt>
               </c:numCache>
             </c:numRef>
           </c:val>
         </c:ser>
         <c:dLbls>
-          <c:numFmt formatCode="0.0#" sourceLinked="0"/>
+          <c:numFmt formatCode="0&quot;%&quot;" sourceLinked="0"/>
           <c:txPr>
             <a:bodyPr/>
             <a:lstStyle/>
@@ -588,7 +670,7 @@
           <a:lstStyle/>
           <a:p>
             <a:pPr>
-              <a:defRPr sz="650" b="0" i="0" u="none" strike="noStrike">
+              <a:defRPr sz="600" b="0" i="0" u="none" strike="noStrike">
                 <a:solidFill>
                   <a:srgbClr val="404040"/>
                 </a:solidFill>
@@ -608,7 +690,7 @@
         <c:axId val="2094734552"/>
         <c:scaling>
           <c:orientation val="minMax"/>
-          <c:max val="1.2"/>
+          <c:max val="85"/>
           <c:min val="0"/>
         </c:scaling>
         <c:delete val="1"/>
@@ -6084,7 +6166,7 @@
                 <a:ea typeface="Microsoft YaHei" pitchFamily="34" charset="-122"/>
                 <a:cs typeface="Microsoft YaHei" pitchFamily="34" charset="-120"/>
               </a:rPr>
-              <a:t>SkillOpt 有界编辑 · eval 门 · Pareto 前沿</a:t>
+              <a:t>SkillOpt 有界编辑 · eval 门 · GEPA/Pareto</a:t>
             </a:r>
             <a:endParaRPr lang="en-US" sz="700" dirty="0"/>
           </a:p>
@@ -6123,7 +6205,7 @@
         <p:spPr>
           <a:xfrm>
             <a:off x="6108192" y="2432304"/>
-            <a:ext cx="3383280" cy="219456"/>
+            <a:ext cx="3584448" cy="219456"/>
           </a:xfrm>
           <a:prstGeom prst="rect">
             <a:avLst/>
@@ -6161,7 +6243,7 @@
                 <a:ea typeface="Microsoft YaHei" pitchFamily="34" charset="-122"/>
                 <a:cs typeface="Microsoft YaHei" pitchFamily="34" charset="-120"/>
               </a:rPr>
-              <a:t>nightly 七步 · semver · broadcast 钉版</a:t>
+              <a:t>nightly 七步 · GEPA 寻优 · semver · broadcast 钉版</a:t>
             </a:r>
             <a:endParaRPr lang="en-US" sz="750" dirty="0"/>
           </a:p>
@@ -6643,7 +6725,7 @@
                 <a:ea typeface="Microsoft YaHei" pitchFamily="34" charset="-122"/>
                 <a:cs typeface="Microsoft YaHei" pitchFamily="34" charset="-120"/>
               </a:rPr>
-              <a:t>创新点2：eval-gate 反喂安全</a:t>
+              <a:t>创新点2：eval门×GEPA 进化</a:t>
             </a:r>
             <a:endParaRPr lang="en-US" sz="850" dirty="0"/>
           </a:p>
@@ -6719,7 +6801,7 @@
                 <a:ea typeface="Microsoft YaHei" pitchFamily="34" charset="-122"/>
                 <a:cs typeface="Microsoft YaHei" pitchFamily="34" charset="-120"/>
               </a:rPr>
-              <a:t>才入库，根治「自增强跑偏」；≥3 次连续改进才解锁自动合并</a:t>
+              <a:t>才入库，根治「自增强跑偏」；引入 GEPA 反思进化 + Pareto 前沿自动寻优技能文本</a:t>
             </a:r>
             <a:endParaRPr lang="en-US" sz="750" dirty="0"/>
           </a:p>
@@ -6758,7 +6840,7 @@
                 <a:ea typeface="Microsoft YaHei" pitchFamily="34" charset="-122"/>
                 <a:cs typeface="Microsoft YaHei" pitchFamily="34" charset="-120"/>
               </a:rPr>
-              <a:t>创新点3：全自动闭环工程化</a:t>
+              <a:t>创新点3：零侵入 · 好上手</a:t>
             </a:r>
             <a:endParaRPr lang="en-US" sz="850" dirty="0"/>
           </a:p>
@@ -6792,7 +6874,7 @@
               <a:buNone/>
             </a:pPr>
             <a:r>
-              <a:rPr lang="en-US" sz="750" dirty="0">
+              <a:rPr lang="en-US" sz="750" b="1" dirty="0">
                 <a:solidFill>
                   <a:srgbClr val="1A1A1A"/>
                 </a:solidFill>
@@ -6800,7 +6882,7 @@
                 <a:ea typeface="Microsoft YaHei" pitchFamily="34" charset="-122"/>
                 <a:cs typeface="Microsoft YaHei" pitchFamily="34" charset="-120"/>
               </a:rPr>
-              <a:t>蒸馏→门控→发布→回灌全自动，人只握晋升审批权；</a:t>
+              <a:t>研发习惯零改动：</a:t>
             </a:r>
             <a:pPr indent="0" marL="0">
               <a:lnSpc>
@@ -6809,7 +6891,7 @@
               <a:buNone/>
             </a:pPr>
             <a:r>
-              <a:rPr lang="en-US" sz="750" b="1" dirty="0">
+              <a:rPr lang="en-US" sz="750" dirty="0">
                 <a:solidFill>
                   <a:srgbClr val="1A1A1A"/>
                 </a:solidFill>
@@ -6817,24 +6899,7 @@
                 <a:ea typeface="Microsoft YaHei" pitchFamily="34" charset="-122"/>
                 <a:cs typeface="Microsoft YaHei" pitchFamily="34" charset="-120"/>
               </a:rPr>
-              <a:t>≥2 独立实例自动毕业为技能</a:t>
-            </a:r>
-            <a:pPr indent="0" marL="0">
-              <a:lnSpc>
-                <a:spcPct val="108000"/>
-              </a:lnSpc>
-              <a:buNone/>
-            </a:pPr>
-            <a:r>
-              <a:rPr lang="en-US" sz="750" dirty="0">
-                <a:solidFill>
-                  <a:srgbClr val="1A1A1A"/>
-                </a:solidFill>
-                <a:latin typeface="Microsoft YaHei" pitchFamily="34" charset="0"/>
-                <a:ea typeface="Microsoft YaHei" pitchFamily="34" charset="-122"/>
-                <a:cs typeface="Microsoft YaHei" pitchFamily="34" charset="-120"/>
-              </a:rPr>
-              <a:t>；MCP 静默降级不阻塞</a:t>
+              <a:t>上下文自动挂载、收口自动蒸馏；MCP 即插即用、故障静默降级；蒸馏到发布全自动闭环，人只做晋升审批</a:t>
             </a:r>
             <a:endParaRPr lang="en-US" sz="750" dirty="0"/>
           </a:p>
@@ -6989,7 +7054,7 @@
                 <a:ea typeface="Microsoft YaHei" pitchFamily="34" charset="-122"/>
                 <a:cs typeface="Microsoft YaHei" pitchFamily="34" charset="-120"/>
               </a:rPr>
-              <a:t>通用：</a:t>
+              <a:t>易用：</a:t>
             </a:r>
             <a:pPr indent="0" marL="0">
               <a:lnSpc>
@@ -7006,7 +7071,24 @@
                 <a:ea typeface="Microsoft YaHei" pitchFamily="34" charset="-122"/>
                 <a:cs typeface="Microsoft YaHei" pitchFamily="34" charset="-120"/>
               </a:rPr>
-              <a:t>底噪 / 指令数 / 功耗 / 编译器后端任意 Agent 优化场景即插即用</a:t>
+              <a:t>研发习惯零改动、MCP 即插即用；新人与新 Agent 冷启动预期</a:t>
+            </a:r>
+            <a:pPr indent="0" marL="0">
+              <a:lnSpc>
+                <a:spcPct val="112000"/>
+              </a:lnSpc>
+              <a:buNone/>
+            </a:pPr>
+            <a:r>
+              <a:rPr lang="en-US" sz="950" b="1" dirty="0">
+                <a:solidFill>
+                  <a:srgbClr val="C00000"/>
+                </a:solidFill>
+                <a:latin typeface="Microsoft YaHei" pitchFamily="34" charset="0"/>
+                <a:ea typeface="Microsoft YaHei" pitchFamily="34" charset="-122"/>
+                <a:cs typeface="Microsoft YaHei" pitchFamily="34" charset="-120"/>
+              </a:rPr>
+              <a:t>从周级降到天级</a:t>
             </a:r>
             <a:endParaRPr lang="en-US" sz="950" dirty="0"/>
           </a:p>
@@ -7040,13 +7122,13 @@
             <a:r>
               <a:rPr lang="en-US" sz="950" b="1" dirty="0">
                 <a:solidFill>
-                  <a:srgbClr val="C00000"/>
-                </a:solidFill>
-                <a:latin typeface="Microsoft YaHei" pitchFamily="34" charset="0"/>
-                <a:ea typeface="Microsoft YaHei" pitchFamily="34" charset="-122"/>
-                <a:cs typeface="Microsoft YaHei" pitchFamily="34" charset="-120"/>
-              </a:rPr>
-              <a:t>落地：</a:t>
+                  <a:srgbClr val="1A1A1A"/>
+                </a:solidFill>
+                <a:latin typeface="Microsoft YaHei" pitchFamily="34" charset="0"/>
+                <a:ea typeface="Microsoft YaHei" pitchFamily="34" charset="-122"/>
+                <a:cs typeface="Microsoft YaHei" pitchFamily="34" charset="-120"/>
+              </a:rPr>
+              <a:t>通用：</a:t>
             </a:r>
             <a:pPr indent="0" marL="0">
               <a:lnSpc>
@@ -7063,7 +7145,7 @@
                 <a:ea typeface="Microsoft YaHei" pitchFamily="34" charset="-122"/>
                 <a:cs typeface="Microsoft YaHei" pitchFamily="34" charset="-120"/>
               </a:rPr>
-              <a:t>双仓全链路已实现——154 项测试 · 7 份 schema · 5 道 CI 门 · 3 个 MCP 工具 · hub v0.2.0 已发版</a:t>
+              <a:t>底噪 / 指令数 / 功耗 / 编译器后端任意 Agent 优化场景即插即用</a:t>
             </a:r>
             <a:endParaRPr lang="en-US" sz="950" dirty="0"/>
           </a:p>
@@ -7134,8 +7216,8 @@
         </p:nvSpPr>
         <p:spPr>
           <a:xfrm>
-            <a:off x="8778240" y="4791456"/>
-            <a:ext cx="1517904" cy="292608"/>
+            <a:off x="8759952" y="4791456"/>
+            <a:ext cx="1682496" cy="292608"/>
           </a:xfrm>
           <a:prstGeom prst="rect">
             <a:avLst/>
@@ -7162,7 +7244,7 @@
                 <a:ea typeface="Microsoft YaHei" pitchFamily="34" charset="-122"/>
                 <a:cs typeface="Microsoft YaHei" pitchFamily="34" charset="-120"/>
               </a:rPr>
-              <a:t>技能优化门（9-case 套件）</a:t>
+              <a:t>经验资产复利（示意）</a:t>
             </a:r>
             <a:endParaRPr lang="en-US" sz="750" dirty="0"/>
           </a:p>
@@ -7174,15 +7256,15 @@
               <a:buNone/>
             </a:pPr>
             <a:r>
-              <a:rPr lang="en-US" sz="700" b="1" dirty="0">
-                <a:solidFill>
-                  <a:srgbClr val="C00000"/>
-                </a:solidFill>
-                <a:latin typeface="Microsoft YaHei" pitchFamily="34" charset="0"/>
-                <a:ea typeface="Microsoft YaHei" pitchFamily="34" charset="-122"/>
-                <a:cs typeface="Microsoft YaHei" pitchFamily="34" charset="-120"/>
-              </a:rPr>
-              <a:t>pass rate 0.67 → 1.00</a:t>
+              <a:rPr lang="en-US" sz="700" dirty="0">
+                <a:solidFill>
+                  <a:srgbClr val="595959"/>
+                </a:solidFill>
+                <a:latin typeface="Microsoft YaHei" pitchFamily="34" charset="0"/>
+                <a:ea typeface="Microsoft YaHei" pitchFamily="34" charset="-122"/>
+                <a:cs typeface="Microsoft YaHei" pitchFamily="34" charset="-120"/>
+              </a:rPr>
+              <a:t>有 Hub 复利 · 无 Hub 随人清零</a:t>
             </a:r>
             <a:endParaRPr lang="en-US" sz="750" dirty="0"/>
           </a:p>
@@ -7195,8 +7277,8 @@
           <p:nvPr/>
         </p:nvGraphicFramePr>
         <p:xfrm>
-          <a:off x="8778240" y="5102352"/>
-          <a:ext cx="1481328" cy="1188720"/>
+          <a:off x="8741664" y="5102352"/>
+          <a:ext cx="1682496" cy="1188720"/>
         </p:xfrm>
         <a:graphic xmlns:a="http://schemas.openxmlformats.org/drawingml/2006/main">
           <a:graphicData uri="http://schemas.openxmlformats.org/drawingml/2006/chart">
@@ -7212,8 +7294,8 @@
         </p:nvSpPr>
         <p:spPr>
           <a:xfrm>
-            <a:off x="10332720" y="4791456"/>
-            <a:ext cx="1517904" cy="292608"/>
+            <a:off x="10497312" y="4791456"/>
+            <a:ext cx="1280160" cy="292608"/>
           </a:xfrm>
           <a:prstGeom prst="rect">
             <a:avLst/>
@@ -7240,7 +7322,7 @@
                 <a:ea typeface="Microsoft YaHei" pitchFamily="34" charset="-122"/>
                 <a:cs typeface="Microsoft YaHei" pitchFamily="34" charset="-120"/>
               </a:rPr>
-              <a:t>检索消融 recall@5</a:t>
+              <a:t>预期收益目标</a:t>
             </a:r>
             <a:endParaRPr lang="en-US" sz="750" dirty="0"/>
           </a:p>
@@ -7260,7 +7342,7 @@
                 <a:ea typeface="Microsoft YaHei" pitchFamily="34" charset="-122"/>
                 <a:cs typeface="Microsoft YaHei" pitchFamily="34" charset="-120"/>
               </a:rPr>
-              <a:t>26 查询 · 混合 ≥ 单臂</a:t>
+              <a:t>相对现状改善幅度（%）</a:t>
             </a:r>
             <a:endParaRPr lang="en-US" sz="750" dirty="0"/>
           </a:p>
@@ -7273,8 +7355,8 @@
           <p:nvPr/>
         </p:nvGraphicFramePr>
         <p:xfrm>
-          <a:off x="10332720" y="5102352"/>
-          <a:ext cx="1444752" cy="1188720"/>
+          <a:off x="10479024" y="5102352"/>
+          <a:ext cx="1298448" cy="1188720"/>
         </p:xfrm>
         <a:graphic xmlns:a="http://schemas.openxmlformats.org/drawingml/2006/main">
           <a:graphicData uri="http://schemas.openxmlformats.org/drawingml/2006/chart">
@@ -7290,8 +7372,8 @@
         </p:nvSpPr>
         <p:spPr>
           <a:xfrm>
-            <a:off x="8778240" y="6364224"/>
-            <a:ext cx="2999232" cy="182880"/>
+            <a:off x="8741664" y="6309360"/>
+            <a:ext cx="3035808" cy="310896"/>
           </a:xfrm>
           <a:prstGeom prst="rect">
             <a:avLst/>
@@ -7300,10 +7382,13 @@
           <a:ln/>
         </p:spPr>
         <p:txBody>
-          <a:bodyPr wrap="square" lIns="0" tIns="0" rIns="0" bIns="0" rtlCol="0" anchor="ctr"/>
+          <a:bodyPr wrap="square" lIns="0" tIns="0" rIns="0" bIns="0" rtlCol="0" anchor="t"/>
           <a:lstStyle/>
           <a:p>
             <a:pPr indent="0" marL="0">
+              <a:lnSpc>
+                <a:spcPct val="110000"/>
+              </a:lnSpc>
               <a:buNone/>
             </a:pPr>
             <a:r>
@@ -7315,7 +7400,27 @@
                 <a:ea typeface="Microsoft YaHei" pitchFamily="34" charset="-122"/>
                 <a:cs typeface="Microsoft YaHei" pitchFamily="34" charset="-120"/>
               </a:rPr>
-              <a:t>* 离线可复现代理套件——控制流已打通，真机 A/B 为下一步</a:t>
+              <a:t>进展：双仓全链路已打通（154 项测试 · 5 道 CI 门 · 离线基准全绿）</a:t>
+            </a:r>
+            <a:endParaRPr lang="en-US" sz="650" dirty="0"/>
+          </a:p>
+          <a:p>
+            <a:pPr indent="0" marL="0">
+              <a:lnSpc>
+                <a:spcPct val="110000"/>
+              </a:lnSpc>
+              <a:buNone/>
+            </a:pPr>
+            <a:r>
+              <a:rPr lang="en-US" sz="650" dirty="0">
+                <a:solidFill>
+                  <a:srgbClr val="595959"/>
+                </a:solidFill>
+                <a:latin typeface="Microsoft YaHei" pitchFamily="34" charset="0"/>
+                <a:ea typeface="Microsoft YaHei" pitchFamily="34" charset="-122"/>
+                <a:cs typeface="Microsoft YaHei" pitchFamily="34" charset="-120"/>
+              </a:rPr>
+              <a:t>GEPA 反思进化集成中 · 真机收益数据随试点回填</a:t>
             </a:r>
             <a:endParaRPr lang="en-US" sz="650" dirty="0"/>
           </a:p>

</xml_diff>

<commit_message>
docs(presentation): swap slide jargon for plain professional terms
Same register shift as the proposal statement, applied to the slide:
curation -> review-and-land, bitemporal tombstones -> superseded records
kept for audit, eval -> benchmark gate, semver/broadcast-pin ->
versioned releases with locked consumers and auto-notify, Pareto ->
keep complementary candidates, distill -> extract, silent degradation ->
auto-skip on failure. Corner-bracket quotes replaced with standard
double quotes to match the shared template's typography.

Co-Authored-By: Claude Fable 5 <noreply@anthropic.com>
Claude-Session: https://claude.ai/code/session_01CH5BZimuCNgDD7CqCtcHvu
</commit_message>
<xml_diff>
--- a/docs/presentation/skill_hub_proposal_onepager.pptx
+++ b/docs/presentation/skill_hub_proposal_onepager.pptx
@@ -1992,7 +1992,7 @@
                 <a:ea typeface="Microsoft YaHei" pitchFamily="34" charset="-122"/>
                 <a:cs typeface="Microsoft YaHei" pitchFamily="34" charset="-120"/>
               </a:rPr>
-              <a:t>——真瓶颈不是「单次优化」，而是</a:t>
+              <a:t>——真瓶颈不是“单次优化”，而是</a:t>
             </a:r>
             <a:pPr indent="0" marL="0">
               <a:lnSpc>
@@ -2009,7 +2009,7 @@
                 <a:ea typeface="Microsoft YaHei" pitchFamily="34" charset="-122"/>
                 <a:cs typeface="Microsoft YaHei" pitchFamily="34" charset="-120"/>
               </a:rPr>
-              <a:t>「经验能否复利积累」</a:t>
+              <a:t>“经验能否复利积累”</a:t>
             </a:r>
             <a:endParaRPr lang="en-US" sz="1000" dirty="0"/>
           </a:p>
@@ -2414,7 +2414,7 @@
                 <a:ea typeface="Microsoft YaHei" pitchFamily="34" charset="-122"/>
                 <a:cs typeface="Microsoft YaHei" pitchFamily="34" charset="-120"/>
               </a:rPr>
-              <a:t>research → 计划评审 → 实现 → 代码评审 → 测试 A/B → 决策</a:t>
+              <a:t>调研 → 计划评审 → 实现 → 代码评审 → 测试 A/B → 决策</a:t>
             </a:r>
             <a:endParaRPr lang="en-US" sz="800" dirty="0"/>
           </a:p>
@@ -2522,7 +2522,7 @@
                 <a:ea typeface="Microsoft YaHei" pitchFamily="34" charset="-122"/>
                 <a:cs typeface="Microsoft YaHei" pitchFamily="34" charset="-120"/>
               </a:rPr>
-              <a:t>idea_ledger（L001 landed −0.8%）· targets 结构事实 · global_lessons · bad_plans</a:t>
+              <a:t>决策台账 idea_ledger（L001 实测 −0.8%）· 结构事实 · 通用教训 · 已否决方案</a:t>
             </a:r>
             <a:endParaRPr lang="en-US" sz="800" dirty="0"/>
           </a:p>
@@ -2903,7 +2903,7 @@
                 <a:ea typeface="Microsoft YaHei" pitchFamily="34" charset="-122"/>
                 <a:cs typeface="Microsoft YaHei" pitchFamily="34" charset="-120"/>
               </a:rPr>
-              <a:t>例：shrink_node「hoist sc-&gt;priority」bench 实测 −0.8%——这类可复用经验此前只躺在个人目录</a:t>
+              <a:t>例：shrink_node 循环不变量外提，实测指令数 −0.8%——这类可复用经验此前只躺在个人目录</a:t>
             </a:r>
             <a:endParaRPr lang="en-US" sz="750" dirty="0"/>
           </a:p>
@@ -2945,7 +2945,7 @@
                 <a:ea typeface="Microsoft YaHei" pitchFamily="34" charset="-122"/>
                 <a:cs typeface="Microsoft YaHei" pitchFamily="34" charset="-120"/>
               </a:rPr>
-              <a:t>业界记忆方案只解决「个体的存与取」；</a:t>
+              <a:t>业界记忆方案只解决“个体的存与取”；</a:t>
             </a:r>
             <a:pPr indent="0" marL="0">
               <a:lnSpc>
@@ -3373,7 +3373,7 @@
                           <a:ea typeface="Microsoft YaHei" pitchFamily="34" charset="-122"/>
                           <a:cs typeface="Microsoft YaHei" pitchFamily="34" charset="-120"/>
                         </a:rPr>
-                        <a:t>团队策展</a:t>
+                        <a:t>团队评审</a:t>
                       </a:r>
                       <a:endParaRPr lang="en-US" sz="750" dirty="0">
                         <a:latin typeface="Microsoft YaHei" charset="0"/>
@@ -3579,7 +3579,7 @@
                           <a:ea typeface="Microsoft YaHei" pitchFamily="34" charset="-122"/>
                           <a:cs typeface="Microsoft YaHei" pitchFamily="34" charset="-120"/>
                         </a:rPr>
-                        <a:t>✗ ADD-only</a:t>
+                        <a:t>✗ 只会追加</a:t>
                       </a:r>
                       <a:endParaRPr lang="en-US" sz="750" dirty="0">
                         <a:latin typeface="Microsoft YaHei" charset="0"/>
@@ -3989,7 +3989,7 @@
                           <a:ea typeface="Microsoft YaHei" pitchFamily="34" charset="-122"/>
                           <a:cs typeface="Microsoft YaHei" pitchFamily="34" charset="-120"/>
                         </a:rPr>
-                        <a:t>△ 双时态</a:t>
+                        <a:t>△ 时效标注</a:t>
                       </a:r>
                       <a:endParaRPr lang="en-US" sz="750" dirty="0">
                         <a:latin typeface="Microsoft YaHei" charset="0"/>
@@ -5219,7 +5219,7 @@
                           <a:ea typeface="Microsoft YaHei" pitchFamily="34" charset="-122"/>
                           <a:cs typeface="Microsoft YaHei" pitchFamily="34" charset="-120"/>
                         </a:rPr>
-                        <a:t>✓ 七路+双时态</a:t>
+                        <a:t>✓ 七类判定</a:t>
                       </a:r>
                       <a:endParaRPr lang="en-US" sz="750" dirty="0">
                         <a:latin typeface="Microsoft YaHei" charset="0"/>
@@ -5287,7 +5287,7 @@
                           <a:ea typeface="Microsoft YaHei" pitchFamily="34" charset="-122"/>
                           <a:cs typeface="Microsoft YaHei" pitchFamily="34" charset="-120"/>
                         </a:rPr>
-                        <a:t>✓ 3门+eval</a:t>
+                        <a:t>✓ 评测把关</a:t>
                       </a:r>
                       <a:endParaRPr lang="en-US" sz="750" dirty="0">
                         <a:latin typeface="Microsoft YaHei" charset="0"/>
@@ -5355,7 +5355,7 @@
                           <a:ea typeface="Microsoft YaHei" pitchFamily="34" charset="-122"/>
                           <a:cs typeface="Microsoft YaHei" pitchFamily="34" charset="-120"/>
                         </a:rPr>
-                        <a:t>✓ semver</a:t>
+                        <a:t>✓ 版本锁定</a:t>
                       </a:r>
                       <a:endParaRPr lang="en-US" sz="750" dirty="0">
                         <a:latin typeface="Microsoft YaHei" charset="0"/>
@@ -5512,7 +5512,7 @@
                 <a:ea typeface="Microsoft YaHei" pitchFamily="34" charset="-122"/>
                 <a:cs typeface="Microsoft YaHei" pitchFamily="34" charset="-120"/>
               </a:rPr>
-              <a:t>∴ 团队级治理层（门控 · 策展 · 版本化）为本方案独有——差异化护城河</a:t>
+              <a:t>团队级治理层（门控 · 审核 · 版本化）为本方案独有——差异化护城河</a:t>
             </a:r>
             <a:endParaRPr lang="en-US" sz="950" dirty="0"/>
           </a:p>
@@ -5565,7 +5565,7 @@
                 <a:ea typeface="Microsoft YaHei" pitchFamily="34" charset="-122"/>
                 <a:cs typeface="Microsoft YaHei" pitchFamily="34" charset="-120"/>
               </a:rPr>
-              <a:t>经验如「私有 npm 包」——消费→蒸馏→门控→发布→再消费，全自动闭环、越用越准</a:t>
+              <a:t>经验像内部软件包一样管理——消费→提炼→门控→发布→再消费，全自动闭环、越用越准</a:t>
             </a:r>
             <a:endParaRPr lang="en-US" sz="1000" dirty="0"/>
           </a:p>
@@ -5643,7 +5643,7 @@
                 <a:ea typeface="Microsoft YaHei" pitchFamily="34" charset="-122"/>
                 <a:cs typeface="Microsoft YaHei" pitchFamily="34" charset="-120"/>
               </a:rPr>
-              <a:t>（semver 发布 · lockfile 钉版 · 可回滚 · 可审计）</a:t>
+              <a:t>（版本化发布 · 各项目锁定消费 · 可回滚 · 可审计）</a:t>
             </a:r>
             <a:endParaRPr lang="en-US" sz="800" dirty="0"/>
           </a:p>
@@ -5710,7 +5710,7 @@
                 <a:ea typeface="Microsoft YaHei" pitchFamily="34" charset="-122"/>
                 <a:cs typeface="Microsoft YaHei" pitchFamily="34" charset="-120"/>
               </a:rPr>
-              <a:t>⑥ 策展入库</a:t>
+              <a:t>⑥ 审核入库</a:t>
             </a:r>
             <a:endParaRPr lang="en-US" sz="650" dirty="0"/>
           </a:p>
@@ -5730,7 +5730,7 @@
                 <a:ea typeface="Microsoft YaHei" pitchFamily="34" charset="-122"/>
                 <a:cs typeface="Microsoft YaHei" pitchFamily="34" charset="-120"/>
               </a:rPr>
-              <a:t>七路分类 · 双人评审</a:t>
+              <a:t>七类关系判定 · 双人评审</a:t>
             </a:r>
             <a:endParaRPr lang="en-US" sz="650" dirty="0"/>
           </a:p>
@@ -5841,7 +5841,7 @@
                 <a:ea typeface="Microsoft YaHei" pitchFamily="34" charset="-122"/>
                 <a:cs typeface="Microsoft YaHei" pitchFamily="34" charset="-120"/>
               </a:rPr>
-              <a:t>lint·脱敏·去重·eval·测试</a:t>
+              <a:t>格式·脱敏·去重·评测·测试</a:t>
             </a:r>
             <a:endParaRPr lang="en-US" sz="650" dirty="0"/>
           </a:p>
@@ -5932,7 +5932,7 @@
                 <a:ea typeface="Microsoft YaHei" pitchFamily="34" charset="-122"/>
                 <a:cs typeface="Microsoft YaHei" pitchFamily="34" charset="-120"/>
               </a:rPr>
-              <a:t>④ staging 收件箱</a:t>
+              <a:t>④ 投稿收件箱</a:t>
             </a:r>
             <a:endParaRPr lang="en-US" sz="650" dirty="0"/>
           </a:p>
@@ -5952,7 +5952,7 @@
                 <a:ea typeface="Microsoft YaHei" pitchFamily="34" charset="-122"/>
                 <a:cs typeface="Microsoft YaHei" pitchFamily="34" charset="-120"/>
               </a:rPr>
-              <a:t>成员蒸馏包投稿 PR</a:t>
+              <a:t>成员提炼包 PR 待审</a:t>
             </a:r>
             <a:endParaRPr lang="en-US" sz="650" dirty="0"/>
           </a:p>
@@ -6059,7 +6059,7 @@
                 <a:ea typeface="Microsoft YaHei" pitchFamily="34" charset="-122"/>
                 <a:cs typeface="Microsoft YaHei" pitchFamily="34" charset="-120"/>
               </a:rPr>
-              <a:t>七路关系分类 · 双时态墓碑 · 永不物删</a:t>
+              <a:t>七类关系判定 · 旧结论留痕不删除</a:t>
             </a:r>
             <a:endParaRPr lang="en-US" sz="700" dirty="0"/>
           </a:p>
@@ -6166,7 +6166,7 @@
                 <a:ea typeface="Microsoft YaHei" pitchFamily="34" charset="-122"/>
                 <a:cs typeface="Microsoft YaHei" pitchFamily="34" charset="-120"/>
               </a:rPr>
-              <a:t>SkillOpt 有界编辑 · eval 门 · GEPA/Pareto</a:t>
+              <a:t>评测门把关 · GEPA 进化 · 多候选保留</a:t>
             </a:r>
             <a:endParaRPr lang="en-US" sz="700" dirty="0"/>
           </a:p>
@@ -6243,7 +6243,7 @@
                 <a:ea typeface="Microsoft YaHei" pitchFamily="34" charset="-122"/>
                 <a:cs typeface="Microsoft YaHei" pitchFamily="34" charset="-120"/>
               </a:rPr>
-              <a:t>nightly 七步 · GEPA 寻优 · semver · broadcast 钉版</a:t>
+              <a:t>每晚自动归并优化（GEPA）· 版本化发布 · 自动通知升级</a:t>
             </a:r>
             <a:endParaRPr lang="en-US" sz="750" dirty="0"/>
           </a:p>
@@ -6321,7 +6321,7 @@
                 <a:ea typeface="Microsoft YaHei" pitchFamily="34" charset="-122"/>
                 <a:cs typeface="Microsoft YaHei" pitchFamily="34" charset="-120"/>
               </a:rPr>
-              <a:t>skill-memory.lock 钉版 + resolve 注入「Hub 上下文」</a:t>
+              <a:t>锁定版本消费 · 按当前函数自动注入团队经验</a:t>
             </a:r>
             <a:endParaRPr lang="en-US" sz="750" dirty="0"/>
           </a:p>
@@ -6423,7 +6423,7 @@
                 <a:ea typeface="Microsoft YaHei" pitchFamily="34" charset="-122"/>
                 <a:cs typeface="Microsoft YaHei" pitchFamily="34" charset="-120"/>
               </a:rPr>
-              <a:t>research → 计划评审 → 实现 → 代码评审 → 测试 → 决策</a:t>
+              <a:t>调研 → 计划评审 → 实现 → 代码评审 → 测试 → 决策</a:t>
             </a:r>
             <a:endParaRPr lang="en-US" sz="750" dirty="0"/>
           </a:p>
@@ -6511,7 +6511,7 @@
                 <a:ea typeface="Microsoft YaHei" pitchFamily="34" charset="-122"/>
                 <a:cs typeface="Microsoft YaHei" pitchFamily="34" charset="-120"/>
               </a:rPr>
-              <a:t>③ 收口蒸馏 sediment：</a:t>
+              <a:t>③ 收口自动提炼：</a:t>
             </a:r>
             <a:pPr indent="0" marL="0">
               <a:buNone/>
@@ -6525,7 +6525,7 @@
                 <a:ea typeface="Microsoft YaHei" pitchFamily="34" charset="-122"/>
                 <a:cs typeface="Microsoft YaHei" pitchFamily="34" charset="-120"/>
               </a:rPr>
-              <a:t>规则 + LLM 双段抽取 → Tier-1 候选 → ④ 投稿 PR</a:t>
+              <a:t>规则 + 大模型双重提取 → 候选记录 → ④ 投稿 PR</a:t>
             </a:r>
             <a:endParaRPr lang="en-US" sz="750" dirty="0"/>
           </a:p>
@@ -6588,7 +6588,7 @@
                 <a:ea typeface="Microsoft YaHei" pitchFamily="34" charset="-122"/>
                 <a:cs typeface="Microsoft YaHei" pitchFamily="34" charset="-120"/>
               </a:rPr>
-              <a:t>MCP：resolve / sediment / status（7338）· hub 不可达静默降级、不阻塞</a:t>
+              <a:t>MCP 接口 3 个工具接入现有流水线 · 经验仓故障自动跳过、不阻塞主流程</a:t>
             </a:r>
             <a:endParaRPr lang="en-US" sz="700" dirty="0"/>
           </a:p>
@@ -6669,7 +6669,7 @@
                 <a:ea typeface="Microsoft YaHei" pitchFamily="34" charset="-122"/>
                 <a:cs typeface="Microsoft YaHei" pitchFamily="34" charset="-120"/>
               </a:rPr>
-              <a:t>知识＝七路关系分类 + 双时态墓碑，永不物删；技能＝SkillOpt + Pareto，eval 门内进化——</a:t>
+              <a:t>知识只增不删：七类关系判定，矛盾留痕可追溯；技能竞争进化：评测把关、多候选保留——</a:t>
             </a:r>
             <a:pPr indent="0" marL="0">
               <a:lnSpc>
@@ -6725,7 +6725,7 @@
                 <a:ea typeface="Microsoft YaHei" pitchFamily="34" charset="-122"/>
                 <a:cs typeface="Microsoft YaHei" pitchFamily="34" charset="-120"/>
               </a:rPr>
-              <a:t>创新点2：eval门×GEPA 进化</a:t>
+              <a:t>创新点2：评测门×GEPA 进化</a:t>
             </a:r>
             <a:endParaRPr lang="en-US" sz="850" dirty="0"/>
           </a:p>
@@ -6767,7 +6767,7 @@
                 <a:ea typeface="Microsoft YaHei" pitchFamily="34" charset="-122"/>
                 <a:cs typeface="Microsoft YaHei" pitchFamily="34" charset="-120"/>
               </a:rPr>
-              <a:t>技能改动须留出套件</a:t>
+              <a:t>技能改动必须在固定评测集上</a:t>
             </a:r>
             <a:pPr indent="0" marL="0">
               <a:lnSpc>
@@ -6784,7 +6784,7 @@
                 <a:ea typeface="Microsoft YaHei" pitchFamily="34" charset="-122"/>
                 <a:cs typeface="Microsoft YaHei" pitchFamily="34" charset="-120"/>
               </a:rPr>
-              <a:t>「严格变好且零回归」</a:t>
+              <a:t>“严格变好且零退化”</a:t>
             </a:r>
             <a:pPr indent="0" marL="0">
               <a:lnSpc>
@@ -6801,7 +6801,7 @@
                 <a:ea typeface="Microsoft YaHei" pitchFamily="34" charset="-122"/>
                 <a:cs typeface="Microsoft YaHei" pitchFamily="34" charset="-120"/>
               </a:rPr>
-              <a:t>才入库，根治「自增强跑偏」；引入 GEPA 反思进化 + Pareto 前沿自动寻优技能文本</a:t>
+              <a:t>才能入库，根治“自增强跑偏”；引入 GEPA 自动反思改写、多候选择优</a:t>
             </a:r>
             <a:endParaRPr lang="en-US" sz="750" dirty="0"/>
           </a:p>
@@ -6899,7 +6899,7 @@
                 <a:ea typeface="Microsoft YaHei" pitchFamily="34" charset="-122"/>
                 <a:cs typeface="Microsoft YaHei" pitchFamily="34" charset="-120"/>
               </a:rPr>
-              <a:t>上下文自动挂载、收口自动蒸馏；MCP 即插即用、故障静默降级；蒸馏到发布全自动闭环，人只做晋升审批</a:t>
+              <a:t>经验自动挂载、收口自动提炼；MCP 即插即用、故障自动跳过；提炼到发布全自动，人只做晋升审批</a:t>
             </a:r>
             <a:endParaRPr lang="en-US" sz="750" dirty="0"/>
           </a:p>
@@ -7202,7 +7202,7 @@
                 <a:ea typeface="Microsoft YaHei" pitchFamily="34" charset="-122"/>
                 <a:cs typeface="Microsoft YaHei" pitchFamily="34" charset="-120"/>
               </a:rPr>
-              <a:t>self-evolving agent 长期记忆——安全积累 · 矛盾治理 · 全程审计</a:t>
+              <a:t>自进化 Agent（self-evolving）长期记忆：安全积累 · 矛盾治理 · 可审计</a:t>
             </a:r>
             <a:endParaRPr lang="en-US" sz="950" dirty="0"/>
           </a:p>

</xml_diff>

<commit_message>
docs(presentation): anchor innovation badges into diagram, merge value bullets
Red numbered badges pin each innovation to its spot in the architecture
diagram (1 bridging the dual knowledge/skills stores, 2 on the skill
store's benchmark/GEPA corner, 3 on the auto-mount stage) and repeat in
front of the innovation column headers. Value panel merges efficiency
and ease-of-use into one bullet and renames the frontier bullet to
research value so the other bullets don't read as non-frontier.

Co-Authored-By: Claude Fable 5 <noreply@anthropic.com>
Claude-Session: https://claude.ai/code/session_01CH5BZimuCNgDD7CqCtcHvu
</commit_message>
<xml_diff>
--- a/docs/presentation/skill_hub_proposal_onepager.pptx
+++ b/docs/presentation/skill_hub_proposal_onepager.pptx
@@ -5967,7 +5967,7 @@
         <p:spPr>
           <a:xfrm>
             <a:off x="5733288" y="1792224"/>
-            <a:ext cx="1938528" cy="548640"/>
+            <a:ext cx="1847088" cy="548640"/>
           </a:xfrm>
           <a:prstGeom prst="rect">
             <a:avLst/>
@@ -5992,7 +5992,7 @@
         <p:spPr>
           <a:xfrm>
             <a:off x="5788152" y="1792224"/>
-            <a:ext cx="1828800" cy="548640"/>
+            <a:ext cx="1737360" cy="548640"/>
           </a:xfrm>
           <a:prstGeom prst="rect">
             <a:avLst/>
@@ -6073,8 +6073,8 @@
         </p:nvSpPr>
         <p:spPr>
           <a:xfrm>
-            <a:off x="7735824" y="1792224"/>
-            <a:ext cx="1938528" cy="548640"/>
+            <a:off x="7827264" y="1792224"/>
+            <a:ext cx="1847088" cy="548640"/>
           </a:xfrm>
           <a:prstGeom prst="rect">
             <a:avLst/>
@@ -6098,8 +6098,8 @@
         </p:nvSpPr>
         <p:spPr>
           <a:xfrm>
-            <a:off x="7790688" y="1792224"/>
-            <a:ext cx="1828800" cy="548640"/>
+            <a:off x="7882128" y="1792224"/>
+            <a:ext cx="1737360" cy="548640"/>
           </a:xfrm>
           <a:prstGeom prst="rect">
             <a:avLst/>
@@ -6166,7 +6166,7 @@
                 <a:ea typeface="Microsoft YaHei" pitchFamily="34" charset="-122"/>
                 <a:cs typeface="Microsoft YaHei" pitchFamily="34" charset="-120"/>
               </a:rPr>
-              <a:t>评测门把关 · GEPA 进化 · 多候选保留</a:t>
+              <a:t>评测把关 · GEPA 进化 · 多候选保留</a:t>
             </a:r>
             <a:endParaRPr lang="en-US" sz="700" dirty="0"/>
           </a:p>
@@ -6175,6 +6175,134 @@
       <p:sp>
         <p:nvSpPr>
           <p:cNvPr id="59" name="Shape 56"/>
+          <p:cNvSpPr/>
+          <p:nvPr/>
+        </p:nvSpPr>
+        <p:spPr>
+          <a:xfrm>
+            <a:off x="7621524" y="1984248"/>
+            <a:ext cx="164592" cy="164592"/>
+          </a:xfrm>
+          <a:prstGeom prst="ellipse">
+            <a:avLst/>
+          </a:prstGeom>
+          <a:solidFill>
+            <a:srgbClr val="C00000"/>
+          </a:solidFill>
+          <a:ln w="12700">
+            <a:solidFill>
+              <a:srgbClr val="FFFFFF"/>
+            </a:solidFill>
+            <a:prstDash val="solid"/>
+          </a:ln>
+        </p:spPr>
+      </p:sp>
+      <p:sp>
+        <p:nvSpPr>
+          <p:cNvPr id="60" name="Text 57"/>
+          <p:cNvSpPr/>
+          <p:nvPr/>
+        </p:nvSpPr>
+        <p:spPr>
+          <a:xfrm>
+            <a:off x="7621524" y="1984248"/>
+            <a:ext cx="164592" cy="164592"/>
+          </a:xfrm>
+          <a:prstGeom prst="rect">
+            <a:avLst/>
+          </a:prstGeom>
+          <a:noFill/>
+          <a:ln/>
+        </p:spPr>
+        <p:txBody>
+          <a:bodyPr wrap="square" lIns="0" tIns="0" rIns="0" bIns="0" rtlCol="0" anchor="ctr"/>
+          <a:lstStyle/>
+          <a:p>
+            <a:pPr algn="ctr" indent="0" marL="0">
+              <a:buNone/>
+            </a:pPr>
+            <a:r>
+              <a:rPr lang="en-US" sz="850" b="1" dirty="0">
+                <a:solidFill>
+                  <a:srgbClr val="FFFFFF"/>
+                </a:solidFill>
+                <a:latin typeface="Microsoft YaHei" pitchFamily="34" charset="0"/>
+                <a:ea typeface="Microsoft YaHei" pitchFamily="34" charset="-122"/>
+                <a:cs typeface="Microsoft YaHei" pitchFamily="34" charset="-120"/>
+              </a:rPr>
+              <a:t>1</a:t>
+            </a:r>
+            <a:endParaRPr lang="en-US" sz="850" dirty="0"/>
+          </a:p>
+        </p:txBody>
+      </p:sp>
+      <p:sp>
+        <p:nvSpPr>
+          <p:cNvPr id="61" name="Shape 58"/>
+          <p:cNvSpPr/>
+          <p:nvPr/>
+        </p:nvSpPr>
+        <p:spPr>
+          <a:xfrm>
+            <a:off x="9482328" y="2139696"/>
+            <a:ext cx="164592" cy="164592"/>
+          </a:xfrm>
+          <a:prstGeom prst="ellipse">
+            <a:avLst/>
+          </a:prstGeom>
+          <a:solidFill>
+            <a:srgbClr val="C00000"/>
+          </a:solidFill>
+          <a:ln w="12700">
+            <a:solidFill>
+              <a:srgbClr val="FFFFFF"/>
+            </a:solidFill>
+            <a:prstDash val="solid"/>
+          </a:ln>
+        </p:spPr>
+      </p:sp>
+      <p:sp>
+        <p:nvSpPr>
+          <p:cNvPr id="62" name="Text 59"/>
+          <p:cNvSpPr/>
+          <p:nvPr/>
+        </p:nvSpPr>
+        <p:spPr>
+          <a:xfrm>
+            <a:off x="9482328" y="2139696"/>
+            <a:ext cx="164592" cy="164592"/>
+          </a:xfrm>
+          <a:prstGeom prst="rect">
+            <a:avLst/>
+          </a:prstGeom>
+          <a:noFill/>
+          <a:ln/>
+        </p:spPr>
+        <p:txBody>
+          <a:bodyPr wrap="square" lIns="0" tIns="0" rIns="0" bIns="0" rtlCol="0" anchor="ctr"/>
+          <a:lstStyle/>
+          <a:p>
+            <a:pPr algn="ctr" indent="0" marL="0">
+              <a:buNone/>
+            </a:pPr>
+            <a:r>
+              <a:rPr lang="en-US" sz="850" b="1" dirty="0">
+                <a:solidFill>
+                  <a:srgbClr val="FFFFFF"/>
+                </a:solidFill>
+                <a:latin typeface="Microsoft YaHei" pitchFamily="34" charset="0"/>
+                <a:ea typeface="Microsoft YaHei" pitchFamily="34" charset="-122"/>
+                <a:cs typeface="Microsoft YaHei" pitchFamily="34" charset="-120"/>
+              </a:rPr>
+              <a:t>2</a:t>
+            </a:r>
+            <a:endParaRPr lang="en-US" sz="850" dirty="0"/>
+          </a:p>
+        </p:txBody>
+      </p:sp>
+      <p:sp>
+        <p:nvSpPr>
+          <p:cNvPr id="63" name="Shape 60"/>
           <p:cNvSpPr/>
           <p:nvPr/>
         </p:nvSpPr>
@@ -6198,7 +6326,7 @@
       </p:sp>
       <p:sp>
         <p:nvSpPr>
-          <p:cNvPr id="60" name="Text 57"/>
+          <p:cNvPr id="64" name="Text 61"/>
           <p:cNvSpPr/>
           <p:nvPr/>
         </p:nvSpPr>
@@ -6251,7 +6379,7 @@
       </p:sp>
       <p:sp>
         <p:nvSpPr>
-          <p:cNvPr id="61" name="Shape 58"/>
+          <p:cNvPr id="65" name="Shape 62"/>
           <p:cNvSpPr/>
           <p:nvPr/>
         </p:nvSpPr>
@@ -6276,7 +6404,7 @@
       </p:sp>
       <p:sp>
         <p:nvSpPr>
-          <p:cNvPr id="62" name="Text 59"/>
+          <p:cNvPr id="66" name="Text 63"/>
           <p:cNvSpPr/>
           <p:nvPr/>
         </p:nvSpPr>
@@ -6329,7 +6457,7 @@
       </p:sp>
       <p:sp>
         <p:nvSpPr>
-          <p:cNvPr id="63" name="Shape 60"/>
+          <p:cNvPr id="67" name="Shape 64"/>
           <p:cNvSpPr/>
           <p:nvPr/>
         </p:nvSpPr>
@@ -6353,7 +6481,7 @@
       </p:sp>
       <p:sp>
         <p:nvSpPr>
-          <p:cNvPr id="64" name="Shape 61"/>
+          <p:cNvPr id="68" name="Shape 65"/>
           <p:cNvSpPr/>
           <p:nvPr/>
         </p:nvSpPr>
@@ -6378,7 +6506,7 @@
       </p:sp>
       <p:sp>
         <p:nvSpPr>
-          <p:cNvPr id="65" name="Text 62"/>
+          <p:cNvPr id="69" name="Text 66"/>
           <p:cNvSpPr/>
           <p:nvPr/>
         </p:nvSpPr>
@@ -6431,7 +6559,7 @@
       </p:sp>
       <p:sp>
         <p:nvSpPr>
-          <p:cNvPr id="66" name="Shape 63"/>
+          <p:cNvPr id="70" name="Shape 67"/>
           <p:cNvSpPr/>
           <p:nvPr/>
         </p:nvSpPr>
@@ -6455,7 +6583,7 @@
       </p:sp>
       <p:sp>
         <p:nvSpPr>
-          <p:cNvPr id="67" name="Shape 64"/>
+          <p:cNvPr id="71" name="Shape 68"/>
           <p:cNvSpPr/>
           <p:nvPr/>
         </p:nvSpPr>
@@ -6480,7 +6608,7 @@
       </p:sp>
       <p:sp>
         <p:nvSpPr>
-          <p:cNvPr id="68" name="Text 65"/>
+          <p:cNvPr id="72" name="Text 69"/>
           <p:cNvSpPr/>
           <p:nvPr/>
         </p:nvSpPr>
@@ -6533,7 +6661,71 @@
       </p:sp>
       <p:sp>
         <p:nvSpPr>
-          <p:cNvPr id="69" name="Shape 66"/>
+          <p:cNvPr id="73" name="Shape 70"/>
+          <p:cNvSpPr/>
+          <p:nvPr/>
+        </p:nvSpPr>
+        <p:spPr>
+          <a:xfrm>
+            <a:off x="9400032" y="2734056"/>
+            <a:ext cx="164592" cy="164592"/>
+          </a:xfrm>
+          <a:prstGeom prst="ellipse">
+            <a:avLst/>
+          </a:prstGeom>
+          <a:solidFill>
+            <a:srgbClr val="C00000"/>
+          </a:solidFill>
+          <a:ln w="12700">
+            <a:solidFill>
+              <a:srgbClr val="FFFFFF"/>
+            </a:solidFill>
+            <a:prstDash val="solid"/>
+          </a:ln>
+        </p:spPr>
+      </p:sp>
+      <p:sp>
+        <p:nvSpPr>
+          <p:cNvPr id="74" name="Text 71"/>
+          <p:cNvSpPr/>
+          <p:nvPr/>
+        </p:nvSpPr>
+        <p:spPr>
+          <a:xfrm>
+            <a:off x="9400032" y="2734056"/>
+            <a:ext cx="164592" cy="164592"/>
+          </a:xfrm>
+          <a:prstGeom prst="rect">
+            <a:avLst/>
+          </a:prstGeom>
+          <a:noFill/>
+          <a:ln/>
+        </p:spPr>
+        <p:txBody>
+          <a:bodyPr wrap="square" lIns="0" tIns="0" rIns="0" bIns="0" rtlCol="0" anchor="ctr"/>
+          <a:lstStyle/>
+          <a:p>
+            <a:pPr algn="ctr" indent="0" marL="0">
+              <a:buNone/>
+            </a:pPr>
+            <a:r>
+              <a:rPr lang="en-US" sz="850" b="1" dirty="0">
+                <a:solidFill>
+                  <a:srgbClr val="FFFFFF"/>
+                </a:solidFill>
+                <a:latin typeface="Microsoft YaHei" pitchFamily="34" charset="0"/>
+                <a:ea typeface="Microsoft YaHei" pitchFamily="34" charset="-122"/>
+                <a:cs typeface="Microsoft YaHei" pitchFamily="34" charset="-120"/>
+              </a:rPr>
+              <a:t>3</a:t>
+            </a:r>
+            <a:endParaRPr lang="en-US" sz="850" dirty="0"/>
+          </a:p>
+        </p:txBody>
+      </p:sp>
+      <p:sp>
+        <p:nvSpPr>
+          <p:cNvPr id="75" name="Shape 72"/>
           <p:cNvSpPr/>
           <p:nvPr/>
         </p:nvSpPr>
@@ -6557,7 +6749,7 @@
       </p:sp>
       <p:sp>
         <p:nvSpPr>
-          <p:cNvPr id="70" name="Text 67"/>
+          <p:cNvPr id="76" name="Text 73"/>
           <p:cNvSpPr/>
           <p:nvPr/>
         </p:nvSpPr>
@@ -6596,14 +6788,78 @@
       </p:sp>
       <p:sp>
         <p:nvSpPr>
-          <p:cNvPr id="71" name="Text 68"/>
-          <p:cNvSpPr/>
-          <p:nvPr/>
-        </p:nvSpPr>
-        <p:spPr>
-          <a:xfrm>
-            <a:off x="9948672" y="1207008"/>
-            <a:ext cx="1810512" cy="182880"/>
+          <p:cNvPr id="77" name="Shape 74"/>
+          <p:cNvSpPr/>
+          <p:nvPr/>
+        </p:nvSpPr>
+        <p:spPr>
+          <a:xfrm>
+            <a:off x="9948672" y="1216152"/>
+            <a:ext cx="164592" cy="164592"/>
+          </a:xfrm>
+          <a:prstGeom prst="ellipse">
+            <a:avLst/>
+          </a:prstGeom>
+          <a:solidFill>
+            <a:srgbClr val="C00000"/>
+          </a:solidFill>
+          <a:ln w="12700">
+            <a:solidFill>
+              <a:srgbClr val="FFFFFF"/>
+            </a:solidFill>
+            <a:prstDash val="solid"/>
+          </a:ln>
+        </p:spPr>
+      </p:sp>
+      <p:sp>
+        <p:nvSpPr>
+          <p:cNvPr id="78" name="Text 75"/>
+          <p:cNvSpPr/>
+          <p:nvPr/>
+        </p:nvSpPr>
+        <p:spPr>
+          <a:xfrm>
+            <a:off x="9948672" y="1216152"/>
+            <a:ext cx="164592" cy="164592"/>
+          </a:xfrm>
+          <a:prstGeom prst="rect">
+            <a:avLst/>
+          </a:prstGeom>
+          <a:noFill/>
+          <a:ln/>
+        </p:spPr>
+        <p:txBody>
+          <a:bodyPr wrap="square" lIns="0" tIns="0" rIns="0" bIns="0" rtlCol="0" anchor="ctr"/>
+          <a:lstStyle/>
+          <a:p>
+            <a:pPr algn="ctr" indent="0" marL="0">
+              <a:buNone/>
+            </a:pPr>
+            <a:r>
+              <a:rPr lang="en-US" sz="850" b="1" dirty="0">
+                <a:solidFill>
+                  <a:srgbClr val="FFFFFF"/>
+                </a:solidFill>
+                <a:latin typeface="Microsoft YaHei" pitchFamily="34" charset="0"/>
+                <a:ea typeface="Microsoft YaHei" pitchFamily="34" charset="-122"/>
+                <a:cs typeface="Microsoft YaHei" pitchFamily="34" charset="-120"/>
+              </a:rPr>
+              <a:t>1</a:t>
+            </a:r>
+            <a:endParaRPr lang="en-US" sz="850" dirty="0"/>
+          </a:p>
+        </p:txBody>
+      </p:sp>
+      <p:sp>
+        <p:nvSpPr>
+          <p:cNvPr id="79" name="Text 76"/>
+          <p:cNvSpPr/>
+          <p:nvPr/>
+        </p:nvSpPr>
+        <p:spPr>
+          <a:xfrm>
+            <a:off x="10168128" y="1207008"/>
+            <a:ext cx="1591056" cy="182880"/>
           </a:xfrm>
           <a:prstGeom prst="rect">
             <a:avLst/>
@@ -6635,7 +6891,7 @@
       </p:sp>
       <p:sp>
         <p:nvSpPr>
-          <p:cNvPr id="72" name="Text 69"/>
+          <p:cNvPr id="80" name="Text 77"/>
           <p:cNvSpPr/>
           <p:nvPr/>
         </p:nvSpPr>
@@ -6694,14 +6950,78 @@
       </p:sp>
       <p:sp>
         <p:nvSpPr>
-          <p:cNvPr id="73" name="Text 70"/>
-          <p:cNvSpPr/>
-          <p:nvPr/>
-        </p:nvSpPr>
-        <p:spPr>
-          <a:xfrm>
-            <a:off x="9948672" y="2176272"/>
-            <a:ext cx="1810512" cy="182880"/>
+          <p:cNvPr id="81" name="Shape 78"/>
+          <p:cNvSpPr/>
+          <p:nvPr/>
+        </p:nvSpPr>
+        <p:spPr>
+          <a:xfrm>
+            <a:off x="9948672" y="2185416"/>
+            <a:ext cx="164592" cy="164592"/>
+          </a:xfrm>
+          <a:prstGeom prst="ellipse">
+            <a:avLst/>
+          </a:prstGeom>
+          <a:solidFill>
+            <a:srgbClr val="C00000"/>
+          </a:solidFill>
+          <a:ln w="12700">
+            <a:solidFill>
+              <a:srgbClr val="FFFFFF"/>
+            </a:solidFill>
+            <a:prstDash val="solid"/>
+          </a:ln>
+        </p:spPr>
+      </p:sp>
+      <p:sp>
+        <p:nvSpPr>
+          <p:cNvPr id="82" name="Text 79"/>
+          <p:cNvSpPr/>
+          <p:nvPr/>
+        </p:nvSpPr>
+        <p:spPr>
+          <a:xfrm>
+            <a:off x="9948672" y="2185416"/>
+            <a:ext cx="164592" cy="164592"/>
+          </a:xfrm>
+          <a:prstGeom prst="rect">
+            <a:avLst/>
+          </a:prstGeom>
+          <a:noFill/>
+          <a:ln/>
+        </p:spPr>
+        <p:txBody>
+          <a:bodyPr wrap="square" lIns="0" tIns="0" rIns="0" bIns="0" rtlCol="0" anchor="ctr"/>
+          <a:lstStyle/>
+          <a:p>
+            <a:pPr algn="ctr" indent="0" marL="0">
+              <a:buNone/>
+            </a:pPr>
+            <a:r>
+              <a:rPr lang="en-US" sz="850" b="1" dirty="0">
+                <a:solidFill>
+                  <a:srgbClr val="FFFFFF"/>
+                </a:solidFill>
+                <a:latin typeface="Microsoft YaHei" pitchFamily="34" charset="0"/>
+                <a:ea typeface="Microsoft YaHei" pitchFamily="34" charset="-122"/>
+                <a:cs typeface="Microsoft YaHei" pitchFamily="34" charset="-120"/>
+              </a:rPr>
+              <a:t>2</a:t>
+            </a:r>
+            <a:endParaRPr lang="en-US" sz="850" dirty="0"/>
+          </a:p>
+        </p:txBody>
+      </p:sp>
+      <p:sp>
+        <p:nvSpPr>
+          <p:cNvPr id="83" name="Text 80"/>
+          <p:cNvSpPr/>
+          <p:nvPr/>
+        </p:nvSpPr>
+        <p:spPr>
+          <a:xfrm>
+            <a:off x="10168128" y="2176272"/>
+            <a:ext cx="1591056" cy="182880"/>
           </a:xfrm>
           <a:prstGeom prst="rect">
             <a:avLst/>
@@ -6725,7 +7045,7 @@
                 <a:ea typeface="Microsoft YaHei" pitchFamily="34" charset="-122"/>
                 <a:cs typeface="Microsoft YaHei" pitchFamily="34" charset="-120"/>
               </a:rPr>
-              <a:t>创新点2：评测门×GEPA 进化</a:t>
+              <a:t>创新点2：评测门×GEPA</a:t>
             </a:r>
             <a:endParaRPr lang="en-US" sz="850" dirty="0"/>
           </a:p>
@@ -6733,7 +7053,7 @@
       </p:sp>
       <p:sp>
         <p:nvSpPr>
-          <p:cNvPr id="74" name="Text 71"/>
+          <p:cNvPr id="84" name="Text 81"/>
           <p:cNvSpPr/>
           <p:nvPr/>
         </p:nvSpPr>
@@ -6809,14 +7129,78 @@
       </p:sp>
       <p:sp>
         <p:nvSpPr>
-          <p:cNvPr id="75" name="Text 72"/>
-          <p:cNvSpPr/>
-          <p:nvPr/>
-        </p:nvSpPr>
-        <p:spPr>
-          <a:xfrm>
-            <a:off x="9948672" y="3145536"/>
-            <a:ext cx="1810512" cy="182880"/>
+          <p:cNvPr id="85" name="Shape 82"/>
+          <p:cNvSpPr/>
+          <p:nvPr/>
+        </p:nvSpPr>
+        <p:spPr>
+          <a:xfrm>
+            <a:off x="9948672" y="3154680"/>
+            <a:ext cx="164592" cy="164592"/>
+          </a:xfrm>
+          <a:prstGeom prst="ellipse">
+            <a:avLst/>
+          </a:prstGeom>
+          <a:solidFill>
+            <a:srgbClr val="C00000"/>
+          </a:solidFill>
+          <a:ln w="12700">
+            <a:solidFill>
+              <a:srgbClr val="FFFFFF"/>
+            </a:solidFill>
+            <a:prstDash val="solid"/>
+          </a:ln>
+        </p:spPr>
+      </p:sp>
+      <p:sp>
+        <p:nvSpPr>
+          <p:cNvPr id="86" name="Text 83"/>
+          <p:cNvSpPr/>
+          <p:nvPr/>
+        </p:nvSpPr>
+        <p:spPr>
+          <a:xfrm>
+            <a:off x="9948672" y="3154680"/>
+            <a:ext cx="164592" cy="164592"/>
+          </a:xfrm>
+          <a:prstGeom prst="rect">
+            <a:avLst/>
+          </a:prstGeom>
+          <a:noFill/>
+          <a:ln/>
+        </p:spPr>
+        <p:txBody>
+          <a:bodyPr wrap="square" lIns="0" tIns="0" rIns="0" bIns="0" rtlCol="0" anchor="ctr"/>
+          <a:lstStyle/>
+          <a:p>
+            <a:pPr algn="ctr" indent="0" marL="0">
+              <a:buNone/>
+            </a:pPr>
+            <a:r>
+              <a:rPr lang="en-US" sz="850" b="1" dirty="0">
+                <a:solidFill>
+                  <a:srgbClr val="FFFFFF"/>
+                </a:solidFill>
+                <a:latin typeface="Microsoft YaHei" pitchFamily="34" charset="0"/>
+                <a:ea typeface="Microsoft YaHei" pitchFamily="34" charset="-122"/>
+                <a:cs typeface="Microsoft YaHei" pitchFamily="34" charset="-120"/>
+              </a:rPr>
+              <a:t>3</a:t>
+            </a:r>
+            <a:endParaRPr lang="en-US" sz="850" dirty="0"/>
+          </a:p>
+        </p:txBody>
+      </p:sp>
+      <p:sp>
+        <p:nvSpPr>
+          <p:cNvPr id="87" name="Text 84"/>
+          <p:cNvSpPr/>
+          <p:nvPr/>
+        </p:nvSpPr>
+        <p:spPr>
+          <a:xfrm>
+            <a:off x="10168128" y="3145536"/>
+            <a:ext cx="1591056" cy="182880"/>
           </a:xfrm>
           <a:prstGeom prst="rect">
             <a:avLst/>
@@ -6840,7 +7224,7 @@
                 <a:ea typeface="Microsoft YaHei" pitchFamily="34" charset="-122"/>
                 <a:cs typeface="Microsoft YaHei" pitchFamily="34" charset="-120"/>
               </a:rPr>
-              <a:t>创新点3：零侵入 · 好上手</a:t>
+              <a:t>创新点3：零侵入·好上手</a:t>
             </a:r>
             <a:endParaRPr lang="en-US" sz="850" dirty="0"/>
           </a:p>
@@ -6848,7 +7232,7 @@
       </p:sp>
       <p:sp>
         <p:nvSpPr>
-          <p:cNvPr id="76" name="Text 73"/>
+          <p:cNvPr id="88" name="Text 85"/>
           <p:cNvSpPr/>
           <p:nvPr/>
         </p:nvSpPr>
@@ -6907,7 +7291,7 @@
       </p:sp>
       <p:sp>
         <p:nvSpPr>
-          <p:cNvPr id="77" name="Text 74"/>
+          <p:cNvPr id="89" name="Text 86"/>
           <p:cNvSpPr/>
           <p:nvPr/>
         </p:nvSpPr>
@@ -6946,7 +7330,7 @@
       </p:sp>
       <p:sp>
         <p:nvSpPr>
-          <p:cNvPr id="78" name="Text 75"/>
+          <p:cNvPr id="90" name="Text 87"/>
           <p:cNvSpPr/>
           <p:nvPr/>
         </p:nvSpPr>
@@ -6967,7 +7351,7 @@
           <a:p>
             <a:pPr indent="0" marL="0">
               <a:lnSpc>
-                <a:spcPct val="112000"/>
+                <a:spcPct val="114000"/>
               </a:lnSpc>
               <a:buNone/>
             </a:pPr>
@@ -6984,7 +7368,7 @@
             </a:r>
             <a:pPr indent="0" marL="0">
               <a:lnSpc>
-                <a:spcPct val="112000"/>
+                <a:spcPct val="114000"/>
               </a:lnSpc>
               <a:buNone/>
             </a:pPr>
@@ -6997,11 +7381,11 @@
                 <a:ea typeface="Microsoft YaHei" pitchFamily="34" charset="-122"/>
                 <a:cs typeface="Microsoft YaHei" pitchFamily="34" charset="-120"/>
               </a:rPr>
-              <a:t>提效：</a:t>
+              <a:t>提效易用：</a:t>
             </a:r>
             <a:pPr indent="0" marL="0">
               <a:lnSpc>
-                <a:spcPct val="112000"/>
+                <a:spcPct val="114000"/>
               </a:lnSpc>
               <a:buNone/>
             </a:pPr>
@@ -7014,17 +7398,34 @@
                 <a:ea typeface="Microsoft YaHei" pitchFamily="34" charset="-122"/>
                 <a:cs typeface="Microsoft YaHei" pitchFamily="34" charset="-120"/>
               </a:rPr>
-              <a:t>告别重复探索与重复踩坑；专家经验成为质量门保护的团队资产，不随人员流失</a:t>
+              <a:t>研发习惯零改动、即插即用；告别重复探索与重复踩坑，专家经验不随人员流失，新人与新 Agent 冷启动预期</a:t>
+            </a:r>
+            <a:pPr indent="0" marL="0">
+              <a:lnSpc>
+                <a:spcPct val="114000"/>
+              </a:lnSpc>
+              <a:buNone/>
+            </a:pPr>
+            <a:r>
+              <a:rPr lang="en-US" sz="950" b="1" dirty="0">
+                <a:solidFill>
+                  <a:srgbClr val="C00000"/>
+                </a:solidFill>
+                <a:latin typeface="Microsoft YaHei" pitchFamily="34" charset="0"/>
+                <a:ea typeface="Microsoft YaHei" pitchFamily="34" charset="-122"/>
+                <a:cs typeface="Microsoft YaHei" pitchFamily="34" charset="-120"/>
+              </a:rPr>
+              <a:t>从周级降到天级</a:t>
             </a:r>
             <a:endParaRPr lang="en-US" sz="950" dirty="0"/>
           </a:p>
           <a:p>
             <a:pPr indent="0" marL="0">
               <a:lnSpc>
-                <a:spcPct val="112000"/>
+                <a:spcPct val="114000"/>
               </a:lnSpc>
               <a:spcBef>
-                <a:spcPts val="300"/>
+                <a:spcPts val="400"/>
               </a:spcBef>
               <a:buNone/>
             </a:pPr>
@@ -7041,7 +7442,7 @@
             </a:r>
             <a:pPr indent="0" marL="0">
               <a:lnSpc>
-                <a:spcPct val="112000"/>
+                <a:spcPct val="114000"/>
               </a:lnSpc>
               <a:buNone/>
             </a:pPr>
@@ -7054,11 +7455,11 @@
                 <a:ea typeface="Microsoft YaHei" pitchFamily="34" charset="-122"/>
                 <a:cs typeface="Microsoft YaHei" pitchFamily="34" charset="-120"/>
               </a:rPr>
-              <a:t>易用：</a:t>
+              <a:t>通用：</a:t>
             </a:r>
             <a:pPr indent="0" marL="0">
               <a:lnSpc>
-                <a:spcPct val="112000"/>
+                <a:spcPct val="114000"/>
               </a:lnSpc>
               <a:buNone/>
             </a:pPr>
@@ -7071,34 +7472,17 @@
                 <a:ea typeface="Microsoft YaHei" pitchFamily="34" charset="-122"/>
                 <a:cs typeface="Microsoft YaHei" pitchFamily="34" charset="-120"/>
               </a:rPr>
-              <a:t>研发习惯零改动、MCP 即插即用；新人与新 Agent 冷启动预期</a:t>
-            </a:r>
-            <a:pPr indent="0" marL="0">
-              <a:lnSpc>
-                <a:spcPct val="112000"/>
-              </a:lnSpc>
-              <a:buNone/>
-            </a:pPr>
-            <a:r>
-              <a:rPr lang="en-US" sz="950" b="1" dirty="0">
-                <a:solidFill>
-                  <a:srgbClr val="C00000"/>
-                </a:solidFill>
-                <a:latin typeface="Microsoft YaHei" pitchFamily="34" charset="0"/>
-                <a:ea typeface="Microsoft YaHei" pitchFamily="34" charset="-122"/>
-                <a:cs typeface="Microsoft YaHei" pitchFamily="34" charset="-120"/>
-              </a:rPr>
-              <a:t>从周级降到天级</a:t>
+              <a:t>不绑定内核——底噪 / 指令数 / 功耗 / 编译器后端等任意 Agent 优化场景直接复用</a:t>
             </a:r>
             <a:endParaRPr lang="en-US" sz="950" dirty="0"/>
           </a:p>
           <a:p>
             <a:pPr indent="0" marL="0">
               <a:lnSpc>
-                <a:spcPct val="112000"/>
+                <a:spcPct val="114000"/>
               </a:lnSpc>
               <a:spcBef>
-                <a:spcPts val="300"/>
+                <a:spcPts val="400"/>
               </a:spcBef>
               <a:buNone/>
             </a:pPr>
@@ -7115,7 +7499,7 @@
             </a:r>
             <a:pPr indent="0" marL="0">
               <a:lnSpc>
-                <a:spcPct val="112000"/>
+                <a:spcPct val="114000"/>
               </a:lnSpc>
               <a:buNone/>
             </a:pPr>
@@ -7128,11 +7512,11 @@
                 <a:ea typeface="Microsoft YaHei" pitchFamily="34" charset="-122"/>
                 <a:cs typeface="Microsoft YaHei" pitchFamily="34" charset="-120"/>
               </a:rPr>
-              <a:t>通用：</a:t>
+              <a:t>研究价值：</a:t>
             </a:r>
             <a:pPr indent="0" marL="0">
               <a:lnSpc>
-                <a:spcPct val="112000"/>
+                <a:spcPct val="114000"/>
               </a:lnSpc>
               <a:buNone/>
             </a:pPr>
@@ -7145,64 +7529,7 @@
                 <a:ea typeface="Microsoft YaHei" pitchFamily="34" charset="-122"/>
                 <a:cs typeface="Microsoft YaHei" pitchFamily="34" charset="-120"/>
               </a:rPr>
-              <a:t>底噪 / 指令数 / 功耗 / 编译器后端任意 Agent 优化场景即插即用</a:t>
-            </a:r>
-            <a:endParaRPr lang="en-US" sz="950" dirty="0"/>
-          </a:p>
-          <a:p>
-            <a:pPr indent="0" marL="0">
-              <a:lnSpc>
-                <a:spcPct val="112000"/>
-              </a:lnSpc>
-              <a:spcBef>
-                <a:spcPts val="300"/>
-              </a:spcBef>
-              <a:buNone/>
-            </a:pPr>
-            <a:r>
-              <a:rPr lang="en-US" sz="950" dirty="0">
-                <a:solidFill>
-                  <a:srgbClr val="1A1A1A"/>
-                </a:solidFill>
-                <a:latin typeface="Microsoft YaHei" pitchFamily="34" charset="0"/>
-                <a:ea typeface="Microsoft YaHei" pitchFamily="34" charset="-122"/>
-                <a:cs typeface="Microsoft YaHei" pitchFamily="34" charset="-120"/>
-              </a:rPr>
-              <a:t>☐ </a:t>
-            </a:r>
-            <a:pPr indent="0" marL="0">
-              <a:lnSpc>
-                <a:spcPct val="112000"/>
-              </a:lnSpc>
-              <a:buNone/>
-            </a:pPr>
-            <a:r>
-              <a:rPr lang="en-US" sz="950" b="1" dirty="0">
-                <a:solidFill>
-                  <a:srgbClr val="1A1A1A"/>
-                </a:solidFill>
-                <a:latin typeface="Microsoft YaHei" pitchFamily="34" charset="0"/>
-                <a:ea typeface="Microsoft YaHei" pitchFamily="34" charset="-122"/>
-                <a:cs typeface="Microsoft YaHei" pitchFamily="34" charset="-120"/>
-              </a:rPr>
-              <a:t>前沿：</a:t>
-            </a:r>
-            <a:pPr indent="0" marL="0">
-              <a:lnSpc>
-                <a:spcPct val="112000"/>
-              </a:lnSpc>
-              <a:buNone/>
-            </a:pPr>
-            <a:r>
-              <a:rPr lang="en-US" sz="950" dirty="0">
-                <a:solidFill>
-                  <a:srgbClr val="1A1A1A"/>
-                </a:solidFill>
-                <a:latin typeface="Microsoft YaHei" pitchFamily="34" charset="0"/>
-                <a:ea typeface="Microsoft YaHei" pitchFamily="34" charset="-122"/>
-                <a:cs typeface="Microsoft YaHei" pitchFamily="34" charset="-120"/>
-              </a:rPr>
-              <a:t>自进化 Agent（self-evolving）长期记忆：安全积累 · 矛盾治理 · 可审计</a:t>
+              <a:t>自进化 Agent（self-evolving）长期记忆的工程化实践：安全积累 · 矛盾治理 · 可审计</a:t>
             </a:r>
             <a:endParaRPr lang="en-US" sz="950" dirty="0"/>
           </a:p>
@@ -7210,7 +7537,7 @@
       </p:sp>
       <p:sp>
         <p:nvSpPr>
-          <p:cNvPr id="79" name="Text 76"/>
+          <p:cNvPr id="91" name="Text 88"/>
           <p:cNvSpPr/>
           <p:nvPr/>
         </p:nvSpPr>
@@ -7272,7 +7599,7 @@
       </p:sp>
       <p:graphicFrame>
         <p:nvGraphicFramePr>
-          <p:cNvPr id="80" name="Chart 0" descr=""/>
+          <p:cNvPr id="92" name="Chart 0" descr=""/>
           <p:cNvGraphicFramePr/>
           <p:nvPr/>
         </p:nvGraphicFramePr>
@@ -7288,7 +7615,7 @@
       </p:graphicFrame>
       <p:sp>
         <p:nvSpPr>
-          <p:cNvPr id="81" name="Text 77"/>
+          <p:cNvPr id="93" name="Text 89"/>
           <p:cNvSpPr/>
           <p:nvPr/>
         </p:nvSpPr>
@@ -7350,7 +7677,7 @@
       </p:sp>
       <p:graphicFrame>
         <p:nvGraphicFramePr>
-          <p:cNvPr id="82" name="Chart 1" descr=""/>
+          <p:cNvPr id="94" name="Chart 1" descr=""/>
           <p:cNvGraphicFramePr/>
           <p:nvPr/>
         </p:nvGraphicFramePr>
@@ -7366,7 +7693,7 @@
       </p:graphicFrame>
       <p:sp>
         <p:nvSpPr>
-          <p:cNvPr id="83" name="Text 78"/>
+          <p:cNvPr id="95" name="Text 90"/>
           <p:cNvSpPr/>
           <p:nvPr/>
         </p:nvSpPr>

</xml_diff>

<commit_message>
docs(presentation): reframe innovations as knowledge/skill/consumption trio
Innovation 1 becomes knowledge-store-focused (trusted knowledge
self-evolution: seven-way semantic relation classification,
evidence-weighted conflict resolution, validity modeling without
deletion, >=2-instance induction bar against false generalization);
innovation 2 adopts the GEPA-based skill self-evolution wording;
innovation 3 becomes scenario-aware smart consumption. Badge 1 moves
from the store seam onto the knowledge store, and the consume stage
mentions scenario-aware recommendation.

Co-Authored-By: Claude Fable 5 <noreply@anthropic.com>
Claude-Session: https://claude.ai/code/session_01CH5BZimuCNgDD7CqCtcHvu
</commit_message>
<xml_diff>
--- a/docs/presentation/skill_hub_proposal_onepager.pptx
+++ b/docs/presentation/skill_hub_proposal_onepager.pptx
@@ -6180,7 +6180,7 @@
         </p:nvSpPr>
         <p:spPr>
           <a:xfrm>
-            <a:off x="7621524" y="1984248"/>
+            <a:off x="7370064" y="2139696"/>
             <a:ext cx="164592" cy="164592"/>
           </a:xfrm>
           <a:prstGeom prst="ellipse">
@@ -6205,7 +6205,7 @@
         </p:nvSpPr>
         <p:spPr>
           <a:xfrm>
-            <a:off x="7621524" y="1984248"/>
+            <a:off x="7370064" y="2139696"/>
             <a:ext cx="164592" cy="164592"/>
           </a:xfrm>
           <a:prstGeom prst="rect">
@@ -6449,7 +6449,7 @@
                 <a:ea typeface="Microsoft YaHei" pitchFamily="34" charset="-122"/>
                 <a:cs typeface="Microsoft YaHei" pitchFamily="34" charset="-120"/>
               </a:rPr>
-              <a:t>锁定版本消费 · 按当前函数自动注入团队经验</a:t>
+              <a:t>锁定版本消费 · 按函数场景智能推荐注入团队经验</a:t>
             </a:r>
             <a:endParaRPr lang="en-US" sz="750" dirty="0"/>
           </a:p>
@@ -6883,7 +6883,7 @@
                 <a:ea typeface="Microsoft YaHei" pitchFamily="34" charset="-122"/>
                 <a:cs typeface="Microsoft YaHei" pitchFamily="34" charset="-120"/>
               </a:rPr>
-              <a:t>创新点1：双资产双引擎</a:t>
+              <a:t>创新点1：知识可信自演化</a:t>
             </a:r>
             <a:endParaRPr lang="en-US" sz="850" dirty="0"/>
           </a:p>
@@ -6917,7 +6917,7 @@
               <a:buNone/>
             </a:pPr>
             <a:r>
-              <a:rPr lang="en-US" sz="750" dirty="0">
+              <a:rPr lang="en-US" sz="750" b="1" dirty="0">
                 <a:solidFill>
                   <a:srgbClr val="1A1A1A"/>
                 </a:solidFill>
@@ -6925,7 +6925,7 @@
                 <a:ea typeface="Microsoft YaHei" pitchFamily="34" charset="-122"/>
                 <a:cs typeface="Microsoft YaHei" pitchFamily="34" charset="-120"/>
               </a:rPr>
-              <a:t>知识只增不删：七类关系判定，矛盾留痕可追溯；技能竞争进化：评测把关、多候选保留——</a:t>
+              <a:t>七类语义关系自动判定</a:t>
             </a:r>
             <a:pPr indent="0" marL="0">
               <a:lnSpc>
@@ -6934,6 +6934,23 @@
               <a:buNone/>
             </a:pPr>
             <a:r>
+              <a:rPr lang="en-US" sz="750" dirty="0">
+                <a:solidFill>
+                  <a:srgbClr val="1A1A1A"/>
+                </a:solidFill>
+                <a:latin typeface="Microsoft YaHei" pitchFamily="34" charset="0"/>
+                <a:ea typeface="Microsoft YaHei" pitchFamily="34" charset="-122"/>
+                <a:cs typeface="Microsoft YaHei" pitchFamily="34" charset="-120"/>
+              </a:rPr>
+              <a:t>（重复/矛盾/过时/条件/泛化/漂移/口径），按证据强度消解矛盾；时效建模失效不删除、可溯源；≥2 独立实例才能归纳为规律，</a:t>
+            </a:r>
+            <a:pPr indent="0" marL="0">
+              <a:lnSpc>
+                <a:spcPct val="108000"/>
+              </a:lnSpc>
+              <a:buNone/>
+            </a:pPr>
+            <a:r>
               <a:rPr lang="en-US" sz="750" b="1" dirty="0">
                 <a:solidFill>
                   <a:srgbClr val="1A1A1A"/>
@@ -6942,7 +6959,7 @@
                 <a:ea typeface="Microsoft YaHei" pitchFamily="34" charset="-122"/>
                 <a:cs typeface="Microsoft YaHei" pitchFamily="34" charset="-120"/>
               </a:rPr>
-              <a:t>业界记忆方案缺失的治理层</a:t>
+              <a:t>防伪泛化</a:t>
             </a:r>
             <a:endParaRPr lang="en-US" sz="750" dirty="0"/>
           </a:p>
@@ -7045,7 +7062,7 @@
                 <a:ea typeface="Microsoft YaHei" pitchFamily="34" charset="-122"/>
                 <a:cs typeface="Microsoft YaHei" pitchFamily="34" charset="-120"/>
               </a:rPr>
-              <a:t>创新点2：评测门×GEPA</a:t>
+              <a:t>创新点2：技能自进化升级</a:t>
             </a:r>
             <a:endParaRPr lang="en-US" sz="850" dirty="0"/>
           </a:p>
@@ -7087,7 +7104,7 @@
                 <a:ea typeface="Microsoft YaHei" pitchFamily="34" charset="-122"/>
                 <a:cs typeface="Microsoft YaHei" pitchFamily="34" charset="-120"/>
               </a:rPr>
-              <a:t>技能改动必须在固定评测集上</a:t>
+              <a:t>基于 GEPA 实现自动反思改写、多候选择优，达到技能自验证与自进化；</a:t>
             </a:r>
             <a:pPr indent="0" marL="0">
               <a:lnSpc>
@@ -7121,7 +7138,7 @@
                 <a:ea typeface="Microsoft YaHei" pitchFamily="34" charset="-122"/>
                 <a:cs typeface="Microsoft YaHei" pitchFamily="34" charset="-120"/>
               </a:rPr>
-              <a:t>才能入库，根治“自增强跑偏”；引入 GEPA 自动反思改写、多候选择优</a:t>
+              <a:t>才能入库，根治“自增强跑偏”</a:t>
             </a:r>
             <a:endParaRPr lang="en-US" sz="750" dirty="0"/>
           </a:p>
@@ -7224,7 +7241,7 @@
                 <a:ea typeface="Microsoft YaHei" pitchFamily="34" charset="-122"/>
                 <a:cs typeface="Microsoft YaHei" pitchFamily="34" charset="-120"/>
               </a:rPr>
-              <a:t>创新点3：零侵入·好上手</a:t>
+              <a:t>创新点3：场景化智能消费</a:t>
             </a:r>
             <a:endParaRPr lang="en-US" sz="850" dirty="0"/>
           </a:p>
@@ -7283,7 +7300,7 @@
                 <a:ea typeface="Microsoft YaHei" pitchFamily="34" charset="-122"/>
                 <a:cs typeface="Microsoft YaHei" pitchFamily="34" charset="-120"/>
               </a:rPr>
-              <a:t>经验自动挂载、收口自动提炼；MCP 即插即用、故障自动跳过；提炼到发布全自动，人只做晋升审批</a:t>
+              <a:t>经验自动挂载、Knowledge/Skill 场景化与个性化智能推荐；收口自动提炼；MCP 即插即用，提炼到发布全自动</a:t>
             </a:r>
             <a:endParaRPr lang="en-US" sz="750" dirty="0"/>
           </a:p>

</xml_diff>